<commit_message>
docs: refine Exadata offload accuracy and contrast
</commit_message>
<xml_diff>
--- a/hermes_docs/oracle-db-storage-bottleneck-exadata.pptx
+++ b/hermes_docs/oracle-db-storage-bottleneck-exadata.pptx
@@ -650,7 +650,7 @@
             <a:r>
               <a:rPr lang="en-US" sz="850" b="1" spc="160" kern="0" dirty="0">
                 <a:solidFill>
-                  <a:srgbClr val="697586"/>
+                  <a:srgbClr val="9CA9BA"/>
                 </a:solidFill>
                 <a:latin typeface="Noto Sans KR" pitchFamily="34" charset="0"/>
                 <a:ea typeface="Noto Sans KR" pitchFamily="34" charset="-122"/>
@@ -687,9 +687,9 @@
               <a:buNone/>
             </a:pPr>
             <a:r>
-              <a:rPr lang="en-US" sz="750" dirty="0">
+              <a:rPr lang="en-US" sz="800" dirty="0">
                 <a:solidFill>
-                  <a:srgbClr val="697586"/>
+                  <a:srgbClr val="9CA9BA"/>
                 </a:solidFill>
                 <a:latin typeface="Noto Sans KR" pitchFamily="34" charset="0"/>
                 <a:ea typeface="Noto Sans KR" pitchFamily="34" charset="-122"/>
@@ -697,7 +697,7 @@
               </a:rPr>
               <a:t>Conceptual architecture · storage I/O bottleneck</a:t>
             </a:r>
-            <a:endParaRPr lang="en-US" sz="750" dirty="0"/>
+            <a:endParaRPr lang="en-US" sz="800" dirty="0"/>
           </a:p>
         </p:txBody>
       </p:sp>
@@ -726,9 +726,9 @@
               <a:buNone/>
             </a:pPr>
             <a:r>
-              <a:rPr lang="en-US" sz="750" dirty="0">
+              <a:rPr lang="en-US" sz="800" dirty="0">
                 <a:solidFill>
-                  <a:srgbClr val="697586"/>
+                  <a:srgbClr val="9CA9BA"/>
                 </a:solidFill>
                 <a:latin typeface="Noto Sans KR" pitchFamily="34" charset="0"/>
                 <a:ea typeface="Noto Sans KR" pitchFamily="34" charset="-122"/>
@@ -736,7 +736,7 @@
               </a:rPr>
               <a:t>Source: Oracle Exadata Database Machine overview</a:t>
             </a:r>
-            <a:endParaRPr lang="en-US" sz="750" dirty="0"/>
+            <a:endParaRPr lang="en-US" sz="800" dirty="0"/>
           </a:p>
         </p:txBody>
       </p:sp>
@@ -1148,7 +1148,7 @@
         <p:spPr>
           <a:xfrm>
             <a:off x="475488" y="292608"/>
-            <a:ext cx="5212080" cy="438912"/>
+            <a:ext cx="6858000" cy="438912"/>
           </a:xfrm>
           <a:prstGeom prst="rect">
             <a:avLst/>
@@ -1174,7 +1174,7 @@
                 <a:ea typeface="Noto Sans KR" pitchFamily="34" charset="-122"/>
                 <a:cs typeface="Noto Sans KR" pitchFamily="34" charset="-120"/>
               </a:rPr>
-              <a:t>Oracle DB 성능의 오래된 병목은</a:t>
+              <a:t>Oracle DB 대규모 분석의 오래된 병목은</a:t>
             </a:r>
             <a:endParaRPr lang="en-US" sz="2500" dirty="0"/>
           </a:p>
@@ -1207,7 +1207,7 @@
               <a:buNone/>
             </a:pPr>
             <a:r>
-              <a:rPr lang="en-US" sz="2800" b="1" dirty="0">
+              <a:rPr lang="en-US" sz="2900" b="1" dirty="0">
                 <a:solidFill>
                   <a:srgbClr val="FF6B5E"/>
                 </a:solidFill>
@@ -1215,9 +1215,9 @@
                 <a:ea typeface="Noto Sans KR" pitchFamily="34" charset="-122"/>
                 <a:cs typeface="Noto Sans KR" pitchFamily="34" charset="-120"/>
               </a:rPr>
-              <a:t>“데이터를 처리하는 CPU”보다 “데이터를 가져오는 I/O”였다</a:t>
-            </a:r>
-            <a:endParaRPr lang="en-US" sz="2800" dirty="0"/>
+              <a:t>CPU 연산보다 데이터 이동·I/O였다</a:t>
+            </a:r>
+            <a:endParaRPr lang="en-US" sz="2900" dirty="0"/>
           </a:p>
         </p:txBody>
       </p:sp>
@@ -1250,7 +1250,7 @@
             <a:r>
               <a:rPr lang="en-US" sz="1000" dirty="0">
                 <a:solidFill>
-                  <a:srgbClr val="B5C0CF"/>
+                  <a:srgbClr val="D2D9E3"/>
                 </a:solidFill>
                 <a:latin typeface="Noto Sans KR" pitchFamily="34" charset="0"/>
                 <a:ea typeface="Noto Sans KR" pitchFamily="34" charset="-122"/>
@@ -2002,7 +2002,7 @@
             <a:r>
               <a:rPr lang="en-US" sz="950" dirty="0">
                 <a:solidFill>
-                  <a:srgbClr val="B5C0CF"/>
+                  <a:srgbClr val="D2D9E3"/>
                 </a:solidFill>
                 <a:latin typeface="Noto Sans KR" pitchFamily="34" charset="0"/>
                 <a:ea typeface="Noto Sans KR" pitchFamily="34" charset="-122"/>
@@ -2365,7 +2365,7 @@
                 <a:ea typeface="Noto Sans KR" pitchFamily="34" charset="-122"/>
                 <a:cs typeface="Noto Sans KR" pitchFamily="34" charset="-120"/>
               </a:rPr>
-              <a:t>SQL 처리를 데이터가 있는 Storage Cell로 이동</a:t>
+              <a:t>Smart Scan 지원 작업을 Storage Cell로 offload</a:t>
             </a:r>
             <a:endParaRPr lang="en-US" sz="1700" dirty="0"/>
           </a:p>
@@ -2648,7 +2648,7 @@
               <a:buNone/>
             </a:pPr>
             <a:r>
-              <a:rPr lang="en-US" sz="880" b="1" dirty="0">
+              <a:rPr lang="en-US" sz="900" b="1" dirty="0">
                 <a:solidFill>
                   <a:srgbClr val="2DD4BF"/>
                 </a:solidFill>
@@ -2656,9 +2656,9 @@
                 <a:ea typeface="Noto Sans KR" pitchFamily="34" charset="-122"/>
                 <a:cs typeface="Noto Sans KR" pitchFamily="34" charset="-120"/>
               </a:rPr>
-              <a:t>필요한 결과만 반환</a:t>
-            </a:r>
-            <a:endParaRPr lang="en-US" sz="880" dirty="0"/>
+              <a:t>축소된 데이터 반환</a:t>
+            </a:r>
+            <a:endParaRPr lang="en-US" sz="900" dirty="0"/>
           </a:p>
         </p:txBody>
       </p:sp>
@@ -2816,13 +2816,13 @@
             <a:r>
               <a:rPr lang="en-US" sz="800" dirty="0">
                 <a:solidFill>
-                  <a:srgbClr val="B5C0CF"/>
+                  <a:srgbClr val="D2D9E3"/>
                 </a:solidFill>
                 <a:latin typeface="Noto Sans KR" pitchFamily="34" charset="0"/>
                 <a:ea typeface="Noto Sans KR" pitchFamily="34" charset="-122"/>
                 <a:cs typeface="Noto Sans KR" pitchFamily="34" charset="-120"/>
               </a:rPr>
-              <a:t>필터 · Projection</a:t>
+              <a:t>스캔 필터 · 열 선택</a:t>
             </a:r>
             <a:endParaRPr lang="en-US" sz="800" dirty="0"/>
           </a:p>
@@ -2982,13 +2982,13 @@
             <a:r>
               <a:rPr lang="en-US" sz="800" dirty="0">
                 <a:solidFill>
-                  <a:srgbClr val="B5C0CF"/>
+                  <a:srgbClr val="D2D9E3"/>
                 </a:solidFill>
                 <a:latin typeface="Noto Sans KR" pitchFamily="34" charset="0"/>
                 <a:ea typeface="Noto Sans KR" pitchFamily="34" charset="-122"/>
                 <a:cs typeface="Noto Sans KR" pitchFamily="34" charset="-120"/>
               </a:rPr>
-              <a:t>불필요 영역 Skip</a:t>
+              <a:t>영역 metadata로 I/O skip</a:t>
             </a:r>
             <a:endParaRPr lang="en-US" sz="800" dirty="0"/>
           </a:p>
@@ -3113,7 +3113,7 @@
                 <a:ea typeface="Noto Sans KR" pitchFamily="34" charset="-122"/>
                 <a:cs typeface="Noto Sans KR" pitchFamily="34" charset="-120"/>
               </a:rPr>
-              <a:t>Parallel Cells</a:t>
+              <a:t>Parallel Offload</a:t>
             </a:r>
             <a:endParaRPr lang="en-US" sz="1050" dirty="0"/>
           </a:p>
@@ -3148,13 +3148,13 @@
             <a:r>
               <a:rPr lang="en-US" sz="800" dirty="0">
                 <a:solidFill>
-                  <a:srgbClr val="B5C0CF"/>
+                  <a:srgbClr val="D2D9E3"/>
                 </a:solidFill>
                 <a:latin typeface="Noto Sans KR" pitchFamily="34" charset="0"/>
                 <a:ea typeface="Noto Sans KR" pitchFamily="34" charset="-122"/>
                 <a:cs typeface="Noto Sans KR" pitchFamily="34" charset="-120"/>
               </a:rPr>
-              <a:t>분산 병렬 처리</a:t>
+              <a:t>여러 Cell이 병렬 처리</a:t>
             </a:r>
             <a:endParaRPr lang="en-US" sz="800" dirty="0"/>
           </a:p>
@@ -3212,13 +3212,13 @@
             <a:r>
               <a:rPr lang="en-US" sz="1100" dirty="0">
                 <a:solidFill>
-                  <a:srgbClr val="B5C0CF"/>
+                  <a:srgbClr val="D2D9E3"/>
                 </a:solidFill>
                 <a:latin typeface="Noto Sans KR" pitchFamily="34" charset="0"/>
                 <a:ea typeface="Noto Sans KR" pitchFamily="34" charset="-122"/>
                 <a:cs typeface="Noto Sans KR" pitchFamily="34" charset="-120"/>
               </a:rPr>
-              <a:t>스토리지는 더 이상 “수동 디스크”가 아니라 SQL-aware processing layer</a:t>
+              <a:t>단순 저장 계층을 SQL-aware offload layer로 확장</a:t>
             </a:r>
             <a:endParaRPr lang="en-US" sz="1100" dirty="0"/>
           </a:p>
@@ -3314,7 +3314,7 @@
                 <a:ea typeface="Noto Sans KR" pitchFamily="34" charset="-122"/>
                 <a:cs typeface="Noto Sans KR" pitchFamily="34" charset="-120"/>
               </a:rPr>
-              <a:t>“스토리지에서 먼저 처리하고 결과만 보내는 방식”</a:t>
+              <a:t>“스토리지에서 먼저 줄이고, 축소된 데이터를 보내는 방식”</a:t>
             </a:r>
             <a:pPr algn="l" indent="0" marL="0">
               <a:buNone/>

</xml_diff>